<commit_message>
Centre logo on closing slide; normal character spacing
Co-Authored-By: Claude Opus 5.5 <noreply@anthropic.com>
</commit_message>
<xml_diff>
--- a/Neudata-Template-example.pptx
+++ b/Neudata-Template-example.pptx
@@ -218,7 +218,7 @@
                 <a:spcPct val="110000"/>
               </a:lnSpc>
               <a:buNone/>
-              <a:defRPr sz="2000" spc="200">
+              <a:defRPr sz="2000">
                 <a:solidFill>
                   <a:srgbClr val="1A1A1A"/>
                 </a:solidFill>
@@ -2012,7 +2012,7 @@
         </p:blipFill>
         <p:spPr>
           <a:xfrm>
-            <a:off x="5207000" y="317500"/>
+            <a:off x="4355465" y="317500"/>
             <a:ext cx="3479800" cy="2413000"/>
           </a:xfrm>
           <a:prstGeom prst="rect">
@@ -2416,7 +2416,7 @@
           <a:spcPct val="0"/>
         </a:spcBef>
         <a:buNone/>
-        <a:defRPr sz="3000" b="1" u="none" strike="noStrike" kern="1200" cap="none" spc="300" normalizeH="0" baseline="0">
+        <a:defRPr sz="3000" b="1" u="none" strike="noStrike" kern="1200" cap="none" normalizeH="0" baseline="0">
           <a:solidFill>
             <a:srgbClr val="0D7377"/>
           </a:solidFill>
@@ -2443,7 +2443,7 @@
         </a:buClr>
         <a:buFont typeface="Arial" panose="020B0604020202020204" pitchFamily="34" charset="0"/>
         <a:buChar char="●"/>
-        <a:defRPr sz="2000" u="none" strike="noStrike" kern="1200" cap="none" spc="150" normalizeH="0" baseline="0">
+        <a:defRPr sz="2000" u="none" strike="noStrike" kern="1200" cap="none" normalizeH="0" baseline="0">
           <a:solidFill>
             <a:srgbClr val="1A1A1A"/>
           </a:solidFill>
@@ -2474,7 +2474,7 @@
           <a:tab pos="1609725" algn="l"/>
           <a:tab pos="1609725" algn="l"/>
         </a:tabLst>
-        <a:defRPr sz="2000" u="none" strike="noStrike" kern="1200" cap="none" spc="150" normalizeH="0" baseline="0">
+        <a:defRPr sz="2000" u="none" strike="noStrike" kern="1200" cap="none" normalizeH="0" baseline="0">
           <a:solidFill>
             <a:srgbClr val="1A1A1A"/>
           </a:solidFill>
@@ -2499,7 +2499,7 @@
         </a:buClr>
         <a:buFont typeface="Arial" panose="020B0604020202020204" pitchFamily="34" charset="0"/>
         <a:buChar char="●"/>
-        <a:defRPr sz="2000" u="none" strike="noStrike" kern="1200" cap="none" spc="150" normalizeH="0" baseline="0">
+        <a:defRPr sz="2000" u="none" strike="noStrike" kern="1200" cap="none" normalizeH="0" baseline="0">
           <a:solidFill>
             <a:srgbClr val="1A1A1A"/>
           </a:solidFill>
@@ -2524,7 +2524,7 @@
         </a:buClr>
         <a:buFont typeface="Wingdings" panose="05000000000000000000" charset="0"/>
         <a:buChar char=""/>
-        <a:defRPr sz="2000" u="none" strike="noStrike" kern="1200" cap="none" spc="150" normalizeH="0" baseline="0">
+        <a:defRPr sz="2000" u="none" strike="noStrike" kern="1200" cap="none" normalizeH="0" baseline="0">
           <a:solidFill>
             <a:srgbClr val="1A1A1A"/>
           </a:solidFill>
@@ -2549,7 +2549,7 @@
         </a:buClr>
         <a:buFont typeface="Arial" panose="020B0604020202020204" pitchFamily="34" charset="0"/>
         <a:buChar char="•"/>
-        <a:defRPr sz="2000" u="none" strike="noStrike" kern="1200" cap="none" spc="150" normalizeH="0" baseline="0">
+        <a:defRPr sz="2000" u="none" strike="noStrike" kern="1200" cap="none" normalizeH="0" baseline="0">
           <a:solidFill>
             <a:srgbClr val="1A1A1A"/>
           </a:solidFill>

</xml_diff>